<commit_message>
Update template title slide with final talk title
Co-Authored-By: Claude Opus 5.5 <noreply@anthropic.com>
Claude-Session: https://claude.ai/code/session_019YyhnWR4xWrB3vjCFnnguR
</commit_message>
<xml_diff>
--- a/Virtual_Translational_Trials_Template.pptx
+++ b/Virtual_Translational_Trials_Template.pptx
@@ -117,32 +117,32 @@
   <p:extLst>
     <p:ext uri="{521415D9-36F7-43E2-AB2F-B90AF26B5E84}">
       <p14:sectionLst xmlns:p14="http://schemas.microsoft.com/office/powerpoint/2010/main">
-        <p14:section name="Opening" id="{317511bd-1764-851b-368a-f76931d93855}">
+        <p14:section name="Opening" id="{939682a2-fc31-3330-79a0-24cf102d0789}">
           <p14:sldIdLst>
             <p14:sldId id="256"/>
             <p14:sldId id="257"/>
           </p14:sldIdLst>
         </p14:section>
-        <p14:section name="Background" id="{b77f74a2-bbd8-9e15-369b-504a2cd50c9e}">
+        <p14:section name="Background" id="{2dc9361f-8aea-760b-d533-35514ecd6f45}">
           <p14:sldIdLst>
             <p14:sldId id="258"/>
             <p14:sldId id="259"/>
           </p14:sldIdLst>
         </p14:section>
-        <p14:section name="Methods" id="{ac5bc548-73d7-9999-5361-4fd344cdb638}">
+        <p14:section name="Methods" id="{2bf27e52-47a8-44c4-8ed4-53d4dccd49c9}">
           <p14:sldIdLst>
             <p14:sldId id="260"/>
             <p14:sldId id="261"/>
           </p14:sldIdLst>
         </p14:section>
-        <p14:section name="Results" id="{213c24b7-1b73-5d9f-e868-d3740ca21c60}">
+        <p14:section name="Results" id="{9f6cd565-8f7b-46ef-10d4-205e9bc6c8e6}">
           <p14:sldIdLst>
             <p14:sldId id="262"/>
             <p14:sldId id="263"/>
             <p14:sldId id="264"/>
           </p14:sldIdLst>
         </p14:section>
-        <p14:section name="Next Steps" id="{8d892fca-d3bc-c2cd-6b55-26f3a30f7694}">
+        <p14:section name="Next Steps" id="{9241535e-2efa-a6ce-a31d-36060a0df30f}">
           <p14:sldIdLst>
             <p14:sldId id="265"/>
             <p14:sldId id="266"/>
@@ -1946,8 +1946,8 @@
         </p:nvSpPr>
         <p:spPr>
           <a:xfrm>
-            <a:off x="640080" y="1828800"/>
-            <a:ext cx="6766560" cy="1737360"/>
+            <a:off x="640080" y="1097280"/>
+            <a:ext cx="6949440" cy="2651760"/>
           </a:xfrm>
           <a:prstGeom prst="rect">
             <a:avLst/>
@@ -1960,7 +1960,7 @@
           <a:lstStyle>
             <a:lvl1pPr algn="l" indent="0" marL="0">
               <a:buNone/>
-              <a:defRPr lang="en-US" sz="5000" b="1" dirty="0">
+              <a:defRPr lang="en-US" sz="4400" b="1" dirty="0">
                 <a:solidFill>
                   <a:srgbClr val="FFFFFF"/>
                 </a:solidFill>
@@ -1975,7 +1975,7 @@
               <a:buNone/>
             </a:pPr>
             <a:r>
-              <a:rPr lang="en-US" sz="5000" b="1" dirty="0">
+              <a:rPr lang="en-US" sz="4400" b="1" dirty="0">
                 <a:solidFill>
                   <a:srgbClr val="FFFFFF"/>
                 </a:solidFill>
@@ -1985,7 +1985,7 @@
               </a:rPr>
               <a:t>Presentation Title</a:t>
             </a:r>
-            <a:endParaRPr lang="en-US" sz="5000" dirty="0"/>
+            <a:endParaRPr lang="en-US" sz="4400" dirty="0"/>
           </a:p>
         </p:txBody>
       </p:sp>
@@ -1999,7 +1999,7 @@
         </p:nvSpPr>
         <p:spPr>
           <a:xfrm>
-            <a:off x="640080" y="3749040"/>
+            <a:off x="640080" y="3931920"/>
             <a:ext cx="6400800" cy="822960"/>
           </a:xfrm>
           <a:prstGeom prst="rect">
@@ -2013,7 +2013,7 @@
           <a:lstStyle>
             <a:lvl1pPr indent="0" marL="0">
               <a:buNone/>
-              <a:defRPr lang="en-US" sz="2000" dirty="0">
+              <a:defRPr lang="en-US" sz="2200" i="1" dirty="0">
                 <a:solidFill>
                   <a:srgbClr val="C4B5FD"/>
                 </a:solidFill>
@@ -2028,7 +2028,7 @@
               <a:buNone/>
             </a:pPr>
             <a:r>
-              <a:rPr lang="en-US" sz="2000" dirty="0">
+              <a:rPr lang="en-US" sz="2200" i="1" dirty="0">
                 <a:solidFill>
                   <a:srgbClr val="C4B5FD"/>
                 </a:solidFill>
@@ -2038,7 +2038,7 @@
               </a:rPr>
               <a:t>Subtitle or study name</a:t>
             </a:r>
-            <a:endParaRPr lang="en-US" sz="2000" dirty="0"/>
+            <a:endParaRPr lang="en-US" sz="2200" dirty="0"/>
           </a:p>
         </p:txBody>
       </p:sp>
@@ -3046,8 +3046,8 @@
         </p:nvSpPr>
         <p:spPr>
           <a:xfrm>
-            <a:off x="640080" y="1828800"/>
-            <a:ext cx="6766560" cy="1737360"/>
+            <a:off x="640080" y="1097280"/>
+            <a:ext cx="6949440" cy="2651760"/>
           </a:xfrm>
           <a:prstGeom prst="rect">
             <a:avLst/>
@@ -3063,7 +3063,7 @@
               <a:buNone/>
             </a:pPr>
             <a:r>
-              <a:rPr lang="en-US" sz="5000" b="1" dirty="0">
+              <a:rPr lang="en-US" sz="4400" b="1" dirty="0">
                 <a:solidFill>
                   <a:srgbClr val="FFFFFF"/>
                 </a:solidFill>
@@ -3071,9 +3071,9 @@
                 <a:ea typeface="Garamond" pitchFamily="34" charset="-122"/>
                 <a:cs typeface="Garamond" pitchFamily="34" charset="-120"/>
               </a:rPr>
-              <a:t>Virtual Translational Trials</a:t>
-            </a:r>
-            <a:endParaRPr lang="en-US" sz="5000" dirty="0"/>
+              <a:t>From Quantitative Imaging to Virtual Translational Trials</a:t>
+            </a:r>
+            <a:endParaRPr lang="en-US" sz="4400" dirty="0"/>
           </a:p>
         </p:txBody>
       </p:sp>
@@ -3087,7 +3087,7 @@
         </p:nvSpPr>
         <p:spPr>
           <a:xfrm>
-            <a:off x="640080" y="3749040"/>
+            <a:off x="640080" y="3931920"/>
             <a:ext cx="6400800" cy="822960"/>
           </a:xfrm>
           <a:prstGeom prst="rect">
@@ -3104,7 +3104,7 @@
               <a:buNone/>
             </a:pPr>
             <a:r>
-              <a:rPr lang="en-US" sz="2000" dirty="0">
+              <a:rPr lang="en-US" sz="2200" i="1" dirty="0">
                 <a:solidFill>
                   <a:srgbClr val="C4B5FD"/>
                 </a:solidFill>
@@ -3112,9 +3112,9 @@
                 <a:ea typeface="Calibri" pitchFamily="34" charset="-122"/>
                 <a:cs typeface="Calibri" pitchFamily="34" charset="-120"/>
               </a:rPr>
-              <a:t>In-silico evidence from bench to bedside</a:t>
-            </a:r>
-            <a:endParaRPr lang="en-US" sz="2000" dirty="0"/>
+              <a:t>Computational Approaches toward Precision Medicine</a:t>
+            </a:r>
+            <a:endParaRPr lang="en-US" sz="2200" dirty="0"/>
           </a:p>
         </p:txBody>
       </p:sp>
@@ -3863,8 +3863,8 @@
         </p:nvSpPr>
         <p:spPr>
           <a:xfrm>
-            <a:off x="640080" y="1828800"/>
-            <a:ext cx="6766560" cy="1737360"/>
+            <a:off x="640080" y="1097280"/>
+            <a:ext cx="6949440" cy="2651760"/>
           </a:xfrm>
           <a:prstGeom prst="rect">
             <a:avLst/>
@@ -3880,7 +3880,7 @@
               <a:buNone/>
             </a:pPr>
             <a:r>
-              <a:rPr lang="en-US" sz="5000" b="1" dirty="0">
+              <a:rPr lang="en-US" sz="4400" b="1" dirty="0">
                 <a:solidFill>
                   <a:srgbClr val="FFFFFF"/>
                 </a:solidFill>
@@ -3890,7 +3890,7 @@
               </a:rPr>
               <a:t>Thank you</a:t>
             </a:r>
-            <a:endParaRPr lang="en-US" sz="5000" dirty="0"/>
+            <a:endParaRPr lang="en-US" sz="4400" dirty="0"/>
           </a:p>
         </p:txBody>
       </p:sp>
@@ -3904,7 +3904,7 @@
         </p:nvSpPr>
         <p:spPr>
           <a:xfrm>
-            <a:off x="640080" y="3749040"/>
+            <a:off x="640080" y="3931920"/>
             <a:ext cx="6400800" cy="822960"/>
           </a:xfrm>
           <a:prstGeom prst="rect">
@@ -3921,7 +3921,7 @@
               <a:buNone/>
             </a:pPr>
             <a:r>
-              <a:rPr lang="en-US" sz="2000" dirty="0">
+              <a:rPr lang="en-US" sz="2200" i="1" dirty="0">
                 <a:solidFill>
                   <a:srgbClr val="C4B5FD"/>
                 </a:solidFill>
@@ -3931,7 +3931,7 @@
               </a:rPr>
               <a:t>Questions &amp; discussion</a:t>
             </a:r>
-            <a:endParaRPr lang="en-US" sz="2000" dirty="0"/>
+            <a:endParaRPr lang="en-US" sz="2200" dirty="0"/>
           </a:p>
         </p:txBody>
       </p:sp>

</xml_diff>